<commit_message>
Refine light theme readability; keep only Dark and Light templates
- Dark navy/slate text on light backgrounds (headings, labels, chart titles)
- Runtime light palette updates for slides, tables, charts, and legend
- Patch meta-ads-light and ga4-light PPTX to replace amber heading text
- Remove six color variants (Ocean/Indigo/Moss/Burgundy/Steel/Copper)
- Migrate clients on retired variants to DARK; enum now DARK + LIGHT only

Co-authored-by: nextreport-app <nextreport-app@users.noreply.github.com>
</commit_message>
<xml_diff>
--- a/templates/ga4-light.pptx
+++ b/templates/ga4-light.pptx
@@ -3287,7 +3287,7 @@
             <a:r>
               <a:rPr b="1" i="0" lang="en-US" sz="6000" u="none" cap="none" strike="noStrike">
                 <a:solidFill>
-                  <a:srgbClr val="F6AD55"/>
+                  <a:srgbClr val="0D1B2E"/>
                 </a:solidFill>
                 <a:latin typeface="Poppins"/>
                 <a:ea typeface="Poppins"/>
@@ -3311,7 +3311,7 @@
             <a:r>
               <a:rPr b="1" i="0" lang="en-US" sz="6000" u="none" cap="none" strike="noStrike">
                 <a:solidFill>
-                  <a:srgbClr val="F6AD55"/>
+                  <a:srgbClr val="0D1B2E"/>
                 </a:solidFill>
                 <a:latin typeface="Poppins"/>
                 <a:ea typeface="Poppins"/>
@@ -7482,7 +7482,7 @@
             <a:r>
               <a:rPr b="0" i="0" lang="en-US" sz="2800" u="none" cap="none" strike="noStrike">
                 <a:solidFill>
-                  <a:srgbClr val="C17D0A"/>
+                  <a:srgbClr val="0D1B2E"/>
                 </a:solidFill>
                 <a:latin typeface="Poppins SemiBold"/>
                 <a:ea typeface="Poppins SemiBold"/>
@@ -10485,7 +10485,7 @@
             <a:r>
               <a:rPr b="0" i="0" lang="en-US" sz="2800" u="none" cap="none" strike="noStrike">
                 <a:solidFill>
-                  <a:srgbClr val="C17D0A"/>
+                  <a:srgbClr val="0D1B2E"/>
                 </a:solidFill>
                 <a:latin typeface="Poppins SemiBold"/>
                 <a:ea typeface="Poppins SemiBold"/>
@@ -10576,7 +10576,7 @@
             <a:r>
               <a:rPr b="0" i="0" lang="en-US" sz="2800" u="none" cap="none" strike="noStrike">
                 <a:solidFill>
-                  <a:srgbClr val="C17D0A"/>
+                  <a:srgbClr val="0D1B2E"/>
                 </a:solidFill>
                 <a:latin typeface="Poppins SemiBold"/>
                 <a:ea typeface="Poppins SemiBold"/>
@@ -15320,7 +15320,7 @@
         <a:srgbClr val="4472C4"/>
       </a:accent1>
       <a:accent2>
-        <a:srgbClr val="ED7D31"/>
+        <a:srgbClr val="0D1B2E"/>
       </a:accent2>
       <a:accent3>
         <a:srgbClr val="A5A5A5"/>

</xml_diff>

<commit_message>
Revert light theme variants; restore single Light with Meta badge
Roll back LIGHT_CREAM/PEARL/SAND to a single LIGHT option. Restore the
original light template including the cover Meta/F gradient badge (shape 24).
Only remove the slide-layout corner ellipse glow — not the badge shading.

Co-authored-by: nextreport-app <nextreport-app@users.noreply.github.com>
</commit_message>
<xml_diff>
--- a/templates/ga4-light.pptx
+++ b/templates/ga4-light.pptx
@@ -3322,6 +3322,93 @@
               <a:ea typeface="Poppins Medium"/>
               <a:cs typeface="Poppins Medium"/>
               <a:sym typeface="Poppins Medium"/>
+            </a:endParaRPr>
+          </a:p>
+        </p:txBody>
+      </p:sp>
+      <p:sp>
+        <p:nvSpPr>
+          <p:cNvPr id="24" name="Google Shape;24;p4"/>
+          <p:cNvSpPr/>
+          <p:nvPr/>
+        </p:nvSpPr>
+        <p:spPr>
+          <a:xfrm>
+            <a:off x="506630" y="5061635"/>
+            <a:ext cx="1745519" cy="331071"/>
+          </a:xfrm>
+          <a:prstGeom prst="roundRect">
+            <a:avLst>
+              <a:gd fmla="val 9840" name="adj"/>
+            </a:avLst>
+          </a:prstGeom>
+          <a:gradFill>
+            <a:gsLst>
+              <a:gs pos="0">
+                <a:schemeClr val="accent2"/>
+              </a:gs>
+              <a:gs pos="5000">
+                <a:schemeClr val="accent2"/>
+              </a:gs>
+              <a:gs pos="41000">
+                <a:schemeClr val="accent1"/>
+              </a:gs>
+              <a:gs pos="75000">
+                <a:schemeClr val="accent3"/>
+              </a:gs>
+              <a:gs pos="100000">
+                <a:schemeClr val="accent4"/>
+              </a:gs>
+            </a:gsLst>
+            <a:lin ang="0" scaled="0"/>
+          </a:gradFill>
+          <a:ln>
+            <a:noFill/>
+          </a:ln>
+        </p:spPr>
+        <p:txBody>
+          <a:bodyPr anchorCtr="0" anchor="ctr" bIns="45700" lIns="91425" spcFirstLastPara="1" rIns="91425" wrap="square" tIns="45700">
+            <a:noAutofit/>
+          </a:bodyPr>
+          <a:lstStyle/>
+          <a:p>
+            <a:pPr indent="0" lvl="0" marL="0" marR="0" rtl="0" algn="ctr">
+              <a:lnSpc>
+                <a:spcPct val="100000"/>
+              </a:lnSpc>
+              <a:spcBef>
+                <a:spcPts val="0"/>
+              </a:spcBef>
+              <a:spcAft>
+                <a:spcPts val="0"/>
+              </a:spcAft>
+              <a:buClr>
+                <a:srgbClr val="000000"/>
+              </a:buClr>
+              <a:buSzPts val="1200"/>
+              <a:buFont typeface="Arial"/>
+              <a:buNone/>
+            </a:pPr>
+            <a:r>
+              <a:rPr b="0" i="0" lang="en-US" sz="1200" u="none" cap="none" strike="noStrike">
+                <a:solidFill>
+                  <a:schemeClr val="lt1"/>
+                </a:solidFill>
+                <a:latin typeface="Poppins Medium"/>
+                <a:ea typeface="Poppins Medium"/>
+                <a:cs typeface="Poppins Medium"/>
+                <a:sym typeface="Poppins Medium"/>
+              </a:rPr>
+              <a:t>PRESENTED TO </a:t>
+            </a:r>
+            <a:endParaRPr b="0" i="0" sz="1400" u="none" cap="none" strike="noStrike">
+              <a:solidFill>
+                <a:srgbClr val="000000"/>
+              </a:solidFill>
+              <a:latin typeface="Arial"/>
+              <a:ea typeface="Arial"/>
+              <a:cs typeface="Arial"/>
+              <a:sym typeface="Arial"/>
             </a:endParaRPr>
           </a:p>
         </p:txBody>

</xml_diff>

<commit_message>
Polish light theme backgrounds and card surfaces
Add soft vertical gradient, thin top brand stripe, and subtle warm glow
on the light slide layout. Soften table header band and metric card
borders. Use white chart/comparison cards with warm sand accents on
from-scratch slides. Keeps Meta/F badge and no corner ellipse.

Co-authored-by: nextreport-app <nextreport-app@users.noreply.github.com>
</commit_message>
<xml_diff>
--- a/templates/ga4-light.pptx
+++ b/templates/ga4-light.pptx
@@ -2192,6 +2192,57 @@
       </p:grpSpPr>
       <p:sp>
         <p:nvSpPr>
+          <p:cNvPr id="101" name="Light Theme Top Accent"/>
+          <p:cNvSpPr/>
+          <p:nvPr/>
+        </p:nvSpPr>
+        <p:spPr>
+          <a:xfrm>
+            <a:off x="0" y="0"/>
+            <a:ext cx="12192000" cy="76200"/>
+          </a:xfrm>
+          <a:prstGeom prst="rect">
+            <a:avLst/>
+          </a:prstGeom>
+          <a:gradFill>
+            <a:gsLst>
+              <a:gs pos="0">
+                <a:srgbClr val="016ED9">
+                  <a:alpha val="38000"/>
+                </a:srgbClr>
+              </a:gs>
+              <a:gs pos="35000">
+                <a:srgbClr val="FF3200">
+                  <a:alpha val="32000"/>
+                </a:srgbClr>
+              </a:gs>
+              <a:gs pos="70000">
+                <a:srgbClr val="FFB300">
+                  <a:alpha val="30000"/>
+                </a:srgbClr>
+              </a:gs>
+              <a:gs pos="100000">
+                <a:srgbClr val="DA32D0">
+                  <a:alpha val="35000"/>
+                </a:srgbClr>
+              </a:gs>
+            </a:gsLst>
+            <a:lin ang="0" scaled="0"/>
+          </a:gradFill>
+          <a:ln>
+            <a:noFill/>
+          </a:ln>
+        </p:spPr>
+        <p:txBody>
+          <a:bodyPr anchorCtr="0" anchor="ctr" bIns="0" lIns="0" rIns="0" tIns="0"/>
+          <a:lstStyle/>
+          <a:p>
+            <a:endParaRPr/>
+          </a:p>
+        </p:txBody>
+      </p:sp>
+      <p:sp>
+        <p:nvSpPr>
           <p:cNvPr id="13" name="Google Shape;13;p2"/>
           <p:cNvSpPr/>
           <p:nvPr/>
@@ -2204,9 +2255,20 @@
           <a:prstGeom prst="rect">
             <a:avLst/>
           </a:prstGeom>
-          <a:solidFill>
-            <a:schemeClr val="accent6"/>
-          </a:solidFill>
+          <a:gradFill>
+            <a:gsLst>
+              <a:gs pos="0">
+                <a:srgbClr val="FFFFFF"/>
+              </a:gs>
+              <a:gs pos="55000">
+                <a:srgbClr val="FDF8F3"/>
+              </a:gs>
+              <a:gs pos="100000">
+                <a:srgbClr val="F3EDE5"/>
+              </a:gs>
+            </a:gsLst>
+            <a:lin ang="5400000" scaled="0"/>
+          </a:gradFill>
           <a:ln>
             <a:noFill/>
           </a:ln>
@@ -2246,6 +2308,47 @@
               <a:cs typeface="Calibri"/>
               <a:sym typeface="Calibri"/>
             </a:endParaRPr>
+          </a:p>
+        </p:txBody>
+      </p:sp>
+      <p:sp>
+        <p:nvSpPr>
+          <p:cNvPr id="102" name="Light Theme Warm Glow"/>
+          <p:cNvSpPr/>
+          <p:nvPr/>
+        </p:nvSpPr>
+        <p:spPr>
+          <a:xfrm>
+            <a:off x="8382000" y="4572000"/>
+            <a:ext cx="3810000" cy="2286000"/>
+          </a:xfrm>
+          <a:prstGeom prst="ellipse">
+            <a:avLst/>
+          </a:prstGeom>
+          <a:gradFill rotWithShape="1">
+            <a:gsLst>
+              <a:gs pos="0">
+                <a:srgbClr val="FFB300">
+                  <a:alpha val="9000"/>
+                </a:srgbClr>
+              </a:gs>
+              <a:gs pos="100000">
+                <a:srgbClr val="FFB300">
+                  <a:alpha val="0"/>
+                </a:srgbClr>
+              </a:gs>
+            </a:gsLst>
+            <a:lin ang="5400000" scaled="0"/>
+          </a:gradFill>
+          <a:ln>
+            <a:noFill/>
+          </a:ln>
+        </p:spPr>
+        <p:txBody>
+          <a:bodyPr anchorCtr="0" anchor="ctr" bIns="0" lIns="0" rIns="0" tIns="0"/>
+          <a:lstStyle/>
+          <a:p>
+            <a:endParaRPr/>
           </a:p>
         </p:txBody>
       </p:sp>
@@ -3711,7 +3814,7 @@
             </a:solidFill>
             <a:ln w="9525">
               <a:solidFill>
-                <a:srgbClr val="F0D9B5"/>
+                <a:srgbClr val="E5DDD0"/>
               </a:solidFill>
             </a:ln>
             <a:effectLst>
@@ -4106,7 +4209,7 @@
             </a:solidFill>
             <a:ln w="9525">
               <a:solidFill>
-                <a:srgbClr val="F0D9B5"/>
+                <a:srgbClr val="E5DDD0"/>
               </a:solidFill>
             </a:ln>
             <a:effectLst>
@@ -4501,7 +4604,7 @@
             </a:solidFill>
             <a:ln w="9525">
               <a:solidFill>
-                <a:srgbClr val="F0D9B5"/>
+                <a:srgbClr val="E5DDD0"/>
               </a:solidFill>
             </a:ln>
             <a:effectLst>
@@ -4896,7 +4999,7 @@
             </a:solidFill>
             <a:ln w="9525">
               <a:solidFill>
-                <a:srgbClr val="F0D9B5"/>
+                <a:srgbClr val="E5DDD0"/>
               </a:solidFill>
             </a:ln>
             <a:effectLst>
@@ -5277,7 +5380,7 @@
           </a:solidFill>
           <a:ln w="9525">
             <a:solidFill>
-              <a:srgbClr val="F0D9B5"/>
+              <a:srgbClr val="E5DDD0"/>
             </a:solidFill>
           </a:ln>
           <a:effectLst>
@@ -5657,7 +5760,7 @@
           </a:solidFill>
           <a:ln w="9525">
             <a:solidFill>
-              <a:srgbClr val="F0D9B5"/>
+              <a:srgbClr val="E5DDD0"/>
             </a:solidFill>
           </a:ln>
           <a:effectLst>
@@ -6037,7 +6140,7 @@
           </a:solidFill>
           <a:ln w="9525">
             <a:solidFill>
-              <a:srgbClr val="F0D9B5"/>
+              <a:srgbClr val="E5DDD0"/>
             </a:solidFill>
           </a:ln>
           <a:effectLst>
@@ -6417,7 +6520,7 @@
           </a:solidFill>
           <a:ln w="9525">
             <a:solidFill>
-              <a:srgbClr val="F0D9B5"/>
+              <a:srgbClr val="E5DDD0"/>
             </a:solidFill>
           </a:ln>
           <a:effectLst>
@@ -7148,9 +7251,6 @@
                   <a:solidFill>
                     <a:srgbClr val="0D1B2E"/>
                   </a:solidFill>
-                  <a:highlight>
-                    <a:srgbClr val="22262B"/>
-                  </a:highlight>
                   <a:latin typeface="Open Sans"/>
                   <a:ea typeface="Open Sans"/>
                   <a:cs typeface="Open Sans"/>
@@ -7579,19 +7679,13 @@
           <a:gradFill>
             <a:gsLst>
               <a:gs pos="0">
-                <a:schemeClr val="accent2"/>
+                <a:srgbClr val="EDE6DA"/>
               </a:gs>
-              <a:gs pos="5000">
-                <a:schemeClr val="accent2"/>
-              </a:gs>
-              <a:gs pos="41000">
-                <a:schemeClr val="accent1"/>
-              </a:gs>
-              <a:gs pos="75000">
-                <a:schemeClr val="accent3"/>
+              <a:gs pos="50000">
+                <a:srgbClr val="D9CCB8"/>
               </a:gs>
               <a:gs pos="100000">
-                <a:schemeClr val="accent4"/>
+                <a:srgbClr val="EDE6DA"/>
               </a:gs>
             </a:gsLst>
             <a:lin ang="0" scaled="0"/>
@@ -7716,7 +7810,7 @@
                   <a:tcPr marT="0" marB="0" marR="63500" marL="63500" anchor="ctr">
                     <a:lnR cap="flat" cmpd="sng" w="19050">
                       <a:solidFill>
-                        <a:srgbClr val="F0D9B5"/>
+                        <a:srgbClr val="E5DDD0"/>
                       </a:solidFill>
                       <a:prstDash val="solid"/>
                       <a:round/>
@@ -7787,7 +7881,7 @@
                   <a:tcPr marT="0" marB="0" marR="63500" marL="63500" anchor="ctr">
                     <a:lnL cap="flat" cmpd="sng" w="19050">
                       <a:solidFill>
-                        <a:srgbClr val="F0D9B5"/>
+                        <a:srgbClr val="E5DDD0"/>
                       </a:solidFill>
                       <a:prstDash val="solid"/>
                       <a:round/>
@@ -7796,7 +7890,7 @@
                     </a:lnL>
                     <a:lnR cap="flat" cmpd="sng" w="19050">
                       <a:solidFill>
-                        <a:srgbClr val="F0D9B5"/>
+                        <a:srgbClr val="E5DDD0"/>
                       </a:solidFill>
                       <a:prstDash val="solid"/>
                       <a:round/>
@@ -7867,7 +7961,7 @@
                   <a:tcPr marT="0" marB="0" marR="63500" marL="63500" anchor="ctr">
                     <a:lnL cap="flat" cmpd="sng" w="19050">
                       <a:solidFill>
-                        <a:srgbClr val="F0D9B5"/>
+                        <a:srgbClr val="E5DDD0"/>
                       </a:solidFill>
                       <a:prstDash val="solid"/>
                       <a:round/>
@@ -7876,7 +7970,7 @@
                     </a:lnL>
                     <a:lnR cap="flat" cmpd="sng" w="19050">
                       <a:solidFill>
-                        <a:srgbClr val="F0D9B5"/>
+                        <a:srgbClr val="E5DDD0"/>
                       </a:solidFill>
                       <a:prstDash val="solid"/>
                       <a:round/>
@@ -7947,7 +8041,7 @@
                   <a:tcPr marT="0" marB="0" marR="63500" marL="63500" anchor="ctr">
                     <a:lnL cap="flat" cmpd="sng" w="19050">
                       <a:solidFill>
-                        <a:srgbClr val="F0D9B5"/>
+                        <a:srgbClr val="E5DDD0"/>
                       </a:solidFill>
                       <a:prstDash val="solid"/>
                       <a:round/>
@@ -7956,7 +8050,7 @@
                     </a:lnL>
                     <a:lnR cap="flat" cmpd="sng" w="19050">
                       <a:solidFill>
-                        <a:srgbClr val="F0D9B5"/>
+                        <a:srgbClr val="E5DDD0"/>
                       </a:solidFill>
                       <a:prstDash val="solid"/>
                       <a:round/>
@@ -8027,7 +8121,7 @@
                   <a:tcPr marT="0" marB="0" marR="63500" marL="63500" anchor="ctr">
                     <a:lnL cap="flat" cmpd="sng" w="19050">
                       <a:solidFill>
-                        <a:srgbClr val="F0D9B5"/>
+                        <a:srgbClr val="E5DDD0"/>
                       </a:solidFill>
                       <a:prstDash val="solid"/>
                       <a:round/>
@@ -8036,7 +8130,7 @@
                     </a:lnL>
                     <a:lnR cap="flat" cmpd="sng" w="19050">
                       <a:solidFill>
-                        <a:srgbClr val="F0D9B5"/>
+                        <a:srgbClr val="E5DDD0"/>
                       </a:solidFill>
                       <a:prstDash val="solid"/>
                       <a:round/>
@@ -8107,7 +8201,7 @@
                   <a:tcPr marT="0" marB="0" marR="63500" marL="63500" anchor="ctr">
                     <a:lnL cap="flat" cmpd="sng" w="19050">
                       <a:solidFill>
-                        <a:srgbClr val="F0D9B5"/>
+                        <a:srgbClr val="E5DDD0"/>
                       </a:solidFill>
                       <a:prstDash val="solid"/>
                       <a:round/>
@@ -8116,7 +8210,7 @@
                     </a:lnL>
                     <a:lnR cap="flat" cmpd="sng" w="19050">
                       <a:solidFill>
-                        <a:srgbClr val="F0D9B5"/>
+                        <a:srgbClr val="E5DDD0"/>
                       </a:solidFill>
                       <a:prstDash val="solid"/>
                       <a:round/>
@@ -8187,7 +8281,7 @@
                   <a:tcPr marT="0" marB="0" marR="63500" marL="63500" anchor="ctr">
                     <a:lnL cap="flat" cmpd="sng" w="19050">
                       <a:solidFill>
-                        <a:srgbClr val="F0D9B5"/>
+                        <a:srgbClr val="E5DDD0"/>
                       </a:solidFill>
                       <a:prstDash val="solid"/>
                       <a:round/>
@@ -8196,7 +8290,7 @@
                     </a:lnL>
                     <a:lnR cap="flat" cmpd="sng" w="19050">
                       <a:solidFill>
-                        <a:srgbClr val="F0D9B5"/>
+                        <a:srgbClr val="E5DDD0"/>
                       </a:solidFill>
                       <a:prstDash val="solid"/>
                       <a:round/>
@@ -8267,7 +8361,7 @@
                   <a:tcPr marT="0" marB="0" marR="63500" marL="63500" anchor="ctr">
                     <a:lnL cap="flat" cmpd="sng" w="19050">
                       <a:solidFill>
-                        <a:srgbClr val="F0D9B5"/>
+                        <a:srgbClr val="E5DDD0"/>
                       </a:solidFill>
                       <a:prstDash val="solid"/>
                       <a:round/>
@@ -8276,7 +8370,7 @@
                     </a:lnL>
                     <a:lnR cap="flat" cmpd="sng" w="19050">
                       <a:solidFill>
-                        <a:srgbClr val="F0D9B5"/>
+                        <a:srgbClr val="E5DDD0"/>
                       </a:solidFill>
                       <a:prstDash val="solid"/>
                       <a:round/>
@@ -8347,7 +8441,7 @@
                   <a:tcPr marT="0" marB="0" marR="63500" marL="63500" anchor="ctr">
                     <a:lnL cap="flat" cmpd="sng" w="19050">
                       <a:solidFill>
-                        <a:srgbClr val="F0D9B5"/>
+                        <a:srgbClr val="E5DDD0"/>
                       </a:solidFill>
                       <a:prstDash val="solid"/>
                       <a:round/>
@@ -8356,7 +8450,7 @@
                     </a:lnL>
                     <a:lnR cap="flat" cmpd="sng" w="19050">
                       <a:solidFill>
-                        <a:srgbClr val="F0D9B5"/>
+                        <a:srgbClr val="E5DDD0"/>
                       </a:solidFill>
                       <a:prstDash val="solid"/>
                       <a:round/>
@@ -8427,7 +8521,7 @@
                   <a:tcPr marT="0" marB="0" marR="63500" marL="63500" anchor="ctr">
                     <a:lnL cap="flat" cmpd="sng" w="19050">
                       <a:solidFill>
-                        <a:srgbClr val="F0D9B5"/>
+                        <a:srgbClr val="E5DDD0"/>
                       </a:solidFill>
                       <a:prstDash val="solid"/>
                       <a:round/>
@@ -8436,7 +8530,7 @@
                     </a:lnL>
                     <a:lnR cap="flat" cmpd="sng" w="19050">
                       <a:solidFill>
-                        <a:srgbClr val="F0D9B5"/>
+                        <a:srgbClr val="E5DDD0"/>
                       </a:solidFill>
                       <a:prstDash val="solid"/>
                       <a:round/>
@@ -10588,7 +10682,7 @@
                 </a:solidFill>
                 <a:ln w="9525">
                   <a:solidFill>
-                    <a:srgbClr val="F0D9B5"/>
+                    <a:srgbClr val="E5DDD0"/>
                   </a:solidFill>
                 </a:ln>
                 <a:effectLst>
@@ -10968,7 +11062,7 @@
                 </a:solidFill>
                 <a:ln w="9525">
                   <a:solidFill>
-                    <a:srgbClr val="F0D9B5"/>
+                    <a:srgbClr val="E5DDD0"/>
                   </a:solidFill>
                 </a:ln>
                 <a:effectLst>
@@ -11348,7 +11442,7 @@
                 </a:solidFill>
                 <a:ln w="9525">
                   <a:solidFill>
-                    <a:srgbClr val="F0D9B5"/>
+                    <a:srgbClr val="E5DDD0"/>
                   </a:solidFill>
                 </a:ln>
                 <a:effectLst>
@@ -11755,7 +11849,7 @@
                 </a:solidFill>
                 <a:ln w="9525">
                   <a:solidFill>
-                    <a:srgbClr val="F0D9B5"/>
+                    <a:srgbClr val="E5DDD0"/>
                   </a:solidFill>
                 </a:ln>
                 <a:effectLst>
@@ -12135,7 +12229,7 @@
                 </a:solidFill>
                 <a:ln w="9525">
                   <a:solidFill>
-                    <a:srgbClr val="F0D9B5"/>
+                    <a:srgbClr val="E5DDD0"/>
                   </a:solidFill>
                 </a:ln>
                 <a:effectLst>
@@ -12515,7 +12609,7 @@
                 </a:solidFill>
                 <a:ln w="9525">
                   <a:solidFill>
-                    <a:srgbClr val="F0D9B5"/>
+                    <a:srgbClr val="E5DDD0"/>
                   </a:solidFill>
                 </a:ln>
                 <a:effectLst>
@@ -12922,7 +13016,7 @@
                 </a:solidFill>
                 <a:ln w="9525">
                   <a:solidFill>
-                    <a:srgbClr val="F0D9B5"/>
+                    <a:srgbClr val="E5DDD0"/>
                   </a:solidFill>
                 </a:ln>
                 <a:effectLst>
@@ -13302,7 +13396,7 @@
                 </a:solidFill>
                 <a:ln w="9525">
                   <a:solidFill>
-                    <a:srgbClr val="F0D9B5"/>
+                    <a:srgbClr val="E5DDD0"/>
                   </a:solidFill>
                 </a:ln>
                 <a:effectLst>
@@ -13694,7 +13788,7 @@
                 </a:solidFill>
                 <a:ln w="9525">
                   <a:solidFill>
-                    <a:srgbClr val="F0D9B5"/>
+                    <a:srgbClr val="E5DDD0"/>
                   </a:solidFill>
                 </a:ln>
                 <a:effectLst>
@@ -14089,7 +14183,7 @@
                 </a:solidFill>
                 <a:ln w="9525">
                   <a:solidFill>
-                    <a:srgbClr val="F0D9B5"/>
+                    <a:srgbClr val="E5DDD0"/>
                   </a:solidFill>
                 </a:ln>
                 <a:effectLst>
@@ -14481,7 +14575,7 @@
                 </a:solidFill>
                 <a:ln w="9525">
                   <a:solidFill>
-                    <a:srgbClr val="F0D9B5"/>
+                    <a:srgbClr val="E5DDD0"/>
                   </a:solidFill>
                 </a:ln>
                 <a:effectLst>
@@ -14873,7 +14967,7 @@
                 </a:solidFill>
                 <a:ln w="9525">
                   <a:solidFill>
-                    <a:srgbClr val="F0D9B5"/>
+                    <a:srgbClr val="E5DDD0"/>
                   </a:solidFill>
                 </a:ln>
                 <a:effectLst>
@@ -15539,7 +15633,7 @@
         <a:srgbClr val="FFFFFF"/>
       </a:accent5>
       <a:accent6>
-        <a:srgbClr val="FDF6EC"/>
+        <a:srgbClr val="FAF8F5"/>
       </a:accent6>
       <a:hlink>
         <a:srgbClr val="0563C1"/>

</xml_diff>